<commit_message>
merge et update du schéma de montage (532nm)
</commit_message>
<xml_diff>
--- a/Projet_2/Cahier_de_lab/PPW_schéma_2.pptx
+++ b/Projet_2/Cahier_de_lab/PPW_schéma_2.pptx
@@ -125,18 +125,18 @@
   <pc:docChgLst>
     <pc:chgData name="Mathilde Noël" userId="e8cc6f8fcd8ecae5" providerId="LiveId" clId="{25374B4B-595F-48B5-8902-A8E8E0647D3A}"/>
     <pc:docChg chg="undo custSel modSld">
-      <pc:chgData name="Mathilde Noël" userId="e8cc6f8fcd8ecae5" providerId="LiveId" clId="{25374B4B-595F-48B5-8902-A8E8E0647D3A}" dt="2026-04-19T19:02:41.462" v="7" actId="1076"/>
+      <pc:chgData name="Mathilde Noël" userId="e8cc6f8fcd8ecae5" providerId="LiveId" clId="{25374B4B-595F-48B5-8902-A8E8E0647D3A}" dt="2026-04-22T02:43:43.623" v="21" actId="207"/>
       <pc:docMkLst>
         <pc:docMk/>
       </pc:docMkLst>
       <pc:sldChg chg="addSp modSp mod">
-        <pc:chgData name="Mathilde Noël" userId="e8cc6f8fcd8ecae5" providerId="LiveId" clId="{25374B4B-595F-48B5-8902-A8E8E0647D3A}" dt="2026-04-19T19:02:41.462" v="7" actId="1076"/>
+        <pc:chgData name="Mathilde Noël" userId="e8cc6f8fcd8ecae5" providerId="LiveId" clId="{25374B4B-595F-48B5-8902-A8E8E0647D3A}" dt="2026-04-22T02:43:43.623" v="21" actId="207"/>
         <pc:sldMkLst>
           <pc:docMk/>
           <pc:sldMk cId="4071592598" sldId="256"/>
         </pc:sldMkLst>
         <pc:spChg chg="mod">
-          <ac:chgData name="Mathilde Noël" userId="e8cc6f8fcd8ecae5" providerId="LiveId" clId="{25374B4B-595F-48B5-8902-A8E8E0647D3A}" dt="2026-04-19T19:02:36.465" v="6" actId="164"/>
+          <ac:chgData name="Mathilde Noël" userId="e8cc6f8fcd8ecae5" providerId="LiveId" clId="{25374B4B-595F-48B5-8902-A8E8E0647D3A}" dt="2026-04-22T02:43:43.623" v="21" actId="207"/>
           <ac:spMkLst>
             <pc:docMk/>
             <pc:sldMk cId="4071592598" sldId="256"/>
@@ -199,14 +199,6 @@
             <ac:spMk id="29" creationId="{7EFE4209-B30C-76F7-E9D9-E7B0F19B4201}"/>
           </ac:spMkLst>
         </pc:spChg>
-        <pc:grpChg chg="add mod">
-          <ac:chgData name="Mathilde Noël" userId="e8cc6f8fcd8ecae5" providerId="LiveId" clId="{25374B4B-595F-48B5-8902-A8E8E0647D3A}" dt="2026-04-19T19:02:30.158" v="5" actId="164"/>
-          <ac:grpSpMkLst>
-            <pc:docMk/>
-            <pc:sldMk cId="4071592598" sldId="256"/>
-            <ac:grpSpMk id="2" creationId="{9DC69003-5C65-7A68-781E-CC83AAD7E666}"/>
-          </ac:grpSpMkLst>
-        </pc:grpChg>
         <pc:grpChg chg="mod">
           <ac:chgData name="Mathilde Noël" userId="e8cc6f8fcd8ecae5" providerId="LiveId" clId="{25374B4B-595F-48B5-8902-A8E8E0647D3A}" dt="2026-04-19T19:02:41.462" v="7" actId="1076"/>
           <ac:grpSpMkLst>
@@ -231,6 +223,14 @@
             <ac:picMk id="15" creationId="{F64C06FC-0510-E2A5-21D9-60112CBDE1A2}"/>
           </ac:picMkLst>
         </pc:picChg>
+        <pc:cxnChg chg="mod">
+          <ac:chgData name="Mathilde Noël" userId="e8cc6f8fcd8ecae5" providerId="LiveId" clId="{25374B4B-595F-48B5-8902-A8E8E0647D3A}" dt="2026-04-22T02:42:55.371" v="20" actId="14100"/>
+          <ac:cxnSpMkLst>
+            <pc:docMk/>
+            <pc:sldMk cId="4071592598" sldId="256"/>
+            <ac:cxnSpMk id="17" creationId="{C7B947C1-1DCB-4FF5-935C-8BFC0EB00FF2}"/>
+          </ac:cxnSpMkLst>
+        </pc:cxnChg>
       </pc:sldChg>
     </pc:docChg>
   </pc:docChgLst>
@@ -386,7 +386,7 @@
           <a:p>
             <a:fld id="{DAA7680F-9B95-42F5-B4F2-D43B2966A08B}" type="datetimeFigureOut">
               <a:rPr lang="fr-CA" smtClean="0"/>
-              <a:t>2026-04-19</a:t>
+              <a:t>2026-04-21</a:t>
             </a:fld>
             <a:endParaRPr lang="fr-CA"/>
           </a:p>
@@ -586,7 +586,7 @@
           <a:p>
             <a:fld id="{DAA7680F-9B95-42F5-B4F2-D43B2966A08B}" type="datetimeFigureOut">
               <a:rPr lang="fr-CA" smtClean="0"/>
-              <a:t>2026-04-19</a:t>
+              <a:t>2026-04-21</a:t>
             </a:fld>
             <a:endParaRPr lang="fr-CA"/>
           </a:p>
@@ -796,7 +796,7 @@
           <a:p>
             <a:fld id="{DAA7680F-9B95-42F5-B4F2-D43B2966A08B}" type="datetimeFigureOut">
               <a:rPr lang="fr-CA" smtClean="0"/>
-              <a:t>2026-04-19</a:t>
+              <a:t>2026-04-21</a:t>
             </a:fld>
             <a:endParaRPr lang="fr-CA"/>
           </a:p>
@@ -996,7 +996,7 @@
           <a:p>
             <a:fld id="{DAA7680F-9B95-42F5-B4F2-D43B2966A08B}" type="datetimeFigureOut">
               <a:rPr lang="fr-CA" smtClean="0"/>
-              <a:t>2026-04-19</a:t>
+              <a:t>2026-04-21</a:t>
             </a:fld>
             <a:endParaRPr lang="fr-CA"/>
           </a:p>
@@ -1272,7 +1272,7 @@
           <a:p>
             <a:fld id="{DAA7680F-9B95-42F5-B4F2-D43B2966A08B}" type="datetimeFigureOut">
               <a:rPr lang="fr-CA" smtClean="0"/>
-              <a:t>2026-04-19</a:t>
+              <a:t>2026-04-21</a:t>
             </a:fld>
             <a:endParaRPr lang="fr-CA"/>
           </a:p>
@@ -1540,7 +1540,7 @@
           <a:p>
             <a:fld id="{DAA7680F-9B95-42F5-B4F2-D43B2966A08B}" type="datetimeFigureOut">
               <a:rPr lang="fr-CA" smtClean="0"/>
-              <a:t>2026-04-19</a:t>
+              <a:t>2026-04-21</a:t>
             </a:fld>
             <a:endParaRPr lang="fr-CA"/>
           </a:p>
@@ -1955,7 +1955,7 @@
           <a:p>
             <a:fld id="{DAA7680F-9B95-42F5-B4F2-D43B2966A08B}" type="datetimeFigureOut">
               <a:rPr lang="fr-CA" smtClean="0"/>
-              <a:t>2026-04-19</a:t>
+              <a:t>2026-04-21</a:t>
             </a:fld>
             <a:endParaRPr lang="fr-CA"/>
           </a:p>
@@ -2097,7 +2097,7 @@
           <a:p>
             <a:fld id="{DAA7680F-9B95-42F5-B4F2-D43B2966A08B}" type="datetimeFigureOut">
               <a:rPr lang="fr-CA" smtClean="0"/>
-              <a:t>2026-04-19</a:t>
+              <a:t>2026-04-21</a:t>
             </a:fld>
             <a:endParaRPr lang="fr-CA"/>
           </a:p>
@@ -2210,7 +2210,7 @@
           <a:p>
             <a:fld id="{DAA7680F-9B95-42F5-B4F2-D43B2966A08B}" type="datetimeFigureOut">
               <a:rPr lang="fr-CA" smtClean="0"/>
-              <a:t>2026-04-19</a:t>
+              <a:t>2026-04-21</a:t>
             </a:fld>
             <a:endParaRPr lang="fr-CA"/>
           </a:p>
@@ -2523,7 +2523,7 @@
           <a:p>
             <a:fld id="{DAA7680F-9B95-42F5-B4F2-D43B2966A08B}" type="datetimeFigureOut">
               <a:rPr lang="fr-CA" smtClean="0"/>
-              <a:t>2026-04-19</a:t>
+              <a:t>2026-04-21</a:t>
             </a:fld>
             <a:endParaRPr lang="fr-CA"/>
           </a:p>
@@ -2812,7 +2812,7 @@
           <a:p>
             <a:fld id="{DAA7680F-9B95-42F5-B4F2-D43B2966A08B}" type="datetimeFigureOut">
               <a:rPr lang="fr-CA" smtClean="0"/>
-              <a:t>2026-04-19</a:t>
+              <a:t>2026-04-21</a:t>
             </a:fld>
             <a:endParaRPr lang="fr-CA"/>
           </a:p>
@@ -3055,7 +3055,7 @@
           <a:p>
             <a:fld id="{DAA7680F-9B95-42F5-B4F2-D43B2966A08B}" type="datetimeFigureOut">
               <a:rPr lang="fr-CA" smtClean="0"/>
-              <a:t>2026-04-19</a:t>
+              <a:t>2026-04-21</a:t>
             </a:fld>
             <a:endParaRPr lang="fr-CA"/>
           </a:p>
@@ -3486,10 +3486,10 @@
         </p:nvGrpSpPr>
         <p:grpSpPr>
           <a:xfrm>
-            <a:off x="3210414" y="702960"/>
-            <a:ext cx="5771172" cy="5452079"/>
-            <a:chOff x="2962952" y="731659"/>
-            <a:chExt cx="5771172" cy="5452079"/>
+            <a:off x="3189055" y="702960"/>
+            <a:ext cx="5792531" cy="5452079"/>
+            <a:chOff x="2941593" y="731659"/>
+            <a:chExt cx="5792531" cy="5452079"/>
           </a:xfrm>
         </p:grpSpPr>
         <p:pic>
@@ -3536,12 +3536,18 @@
           </p:nvSpPr>
           <p:spPr>
             <a:xfrm>
-              <a:off x="2962952" y="5329351"/>
-              <a:ext cx="1757144" cy="460249"/>
+              <a:off x="2941593" y="5334193"/>
+              <a:ext cx="1757144" cy="487500"/>
             </a:xfrm>
             <a:prstGeom prst="roundRect">
               <a:avLst/>
             </a:prstGeom>
+            <a:solidFill>
+              <a:schemeClr val="accent6">
+                <a:lumMod val="20000"/>
+                <a:lumOff val="80000"/>
+              </a:schemeClr>
+            </a:solidFill>
           </p:spPr>
           <p:style>
             <a:lnRef idx="2">
@@ -3565,6 +3571,13 @@
               <a:r>
                 <a:rPr lang="fr-CA" sz="1400" dirty="0"/>
                 <a:t>Laser vert</a:t>
+              </a:r>
+            </a:p>
+            <a:p>
+              <a:pPr algn="ctr"/>
+              <a:r>
+                <a:rPr lang="fr-CA" sz="1400" dirty="0"/>
+                <a:t> (532 nm)</a:t>
               </a:r>
             </a:p>
           </p:txBody>
@@ -3830,9 +3843,9 @@
             <p:nvPr/>
           </p:nvCxnSpPr>
           <p:spPr>
-            <a:xfrm>
-              <a:off x="4720096" y="5559475"/>
-              <a:ext cx="2383160" cy="0"/>
+            <a:xfrm flipV="1">
+              <a:off x="4698737" y="5559476"/>
+              <a:ext cx="2404519" cy="18467"/>
             </a:xfrm>
             <a:prstGeom prst="line">
               <a:avLst/>

</xml_diff>